<commit_message>
docs: atualizacao diagram ade pacote
</commit_message>
<xml_diff>
--- a/Apresentacao/Faitec_2026_EldeConnect-Rev.pptx
+++ b/Apresentacao/Faitec_2026_EldeConnect-Rev.pptx
@@ -32,14 +32,14 @@
   <p:notesSz cx="6858000" cy="9144000"/>
   <p:embeddedFontLst>
     <p:embeddedFont>
-      <p:font typeface="Helvetica Neue" charset="0"/>
+      <p:font typeface="Helvetica Neue Light" charset="0"/>
       <p:regular r:id="rId22"/>
       <p:bold r:id="rId23"/>
       <p:italic r:id="rId24"/>
       <p:boldItalic r:id="rId25"/>
     </p:embeddedFont>
     <p:embeddedFont>
-      <p:font typeface="Helvetica Neue Light" charset="0"/>
+      <p:font typeface="Helvetica Neue" charset="0"/>
       <p:regular r:id="rId26"/>
       <p:bold r:id="rId27"/>
       <p:italic r:id="rId28"/>
@@ -277,7 +277,7 @@
   </p:defaultTextStyle>
   <p:extLst>
     <p:ext uri="GoogleSlidesCustomDataVersion2">
-      <go:slidesCustomData xmlns:go="http://customooxmlschemas.google.com/" xmlns:ahyp="http://schemas.microsoft.com/office/drawing/2018/hyperlinkcolor" xmlns:p15="http://schemas.microsoft.com/office/powerpoint/2012/main" xmlns:p14="http://schemas.microsoft.com/office/powerpoint/2010/main" xmlns:com="http://schemas.openxmlformats.org/drawingml/2006/compatibility" xmlns:pvml="urn:schemas-microsoft-com:office:powerpoint" xmlns:v="urn:schemas-microsoft-com:vml" xmlns:o="urn:schemas-microsoft-com:office:office" xmlns:dgm="http://schemas.openxmlformats.org/drawingml/2006/diagram" xmlns:c="http://schemas.openxmlformats.org/drawingml/2006/chart" xmlns:mv="urn:schemas-microsoft-com:mac:vml" xmlns:mc="http://schemas.openxmlformats.org/markup-compatibility/2006" xmlns="" r:id="rId30" roundtripDataSignature="AMtx7mgZ84KggsQfQCuyVjL79bhoOGuyfA=="/>
+      <go:slidesCustomData xmlns="" xmlns:mc="http://schemas.openxmlformats.org/markup-compatibility/2006" xmlns:mv="urn:schemas-microsoft-com:mac:vml" xmlns:c="http://schemas.openxmlformats.org/drawingml/2006/chart" xmlns:dgm="http://schemas.openxmlformats.org/drawingml/2006/diagram" xmlns:o="urn:schemas-microsoft-com:office:office" xmlns:v="urn:schemas-microsoft-com:vml" xmlns:pvml="urn:schemas-microsoft-com:office:powerpoint" xmlns:com="http://schemas.openxmlformats.org/drawingml/2006/compatibility" xmlns:p14="http://schemas.microsoft.com/office/powerpoint/2010/main" xmlns:p15="http://schemas.microsoft.com/office/powerpoint/2012/main" xmlns:ahyp="http://schemas.microsoft.com/office/drawing/2018/hyperlinkcolor" xmlns:go="http://customooxmlschemas.google.com/" r:id="rId30" roundtripDataSignature="AMtx7mgZ84KggsQfQCuyVjL79bhoOGuyfA=="/>
     </p:ext>
   </p:extLst>
 </p:presentation>
@@ -4189,8 +4189,8 @@
         </p:nvSpPr>
         <p:spPr>
           <a:xfrm>
-            <a:off x="6733230" y="2603233"/>
-            <a:ext cx="7992888" cy="1764586"/>
+            <a:off x="6733230" y="3018731"/>
+            <a:ext cx="11579450" cy="933589"/>
           </a:xfrm>
           <a:prstGeom prst="rect">
             <a:avLst/>
@@ -4397,8 +4397,8 @@
         </p:nvSpPr>
         <p:spPr>
           <a:xfrm>
-            <a:off x="6685572" y="3133448"/>
-            <a:ext cx="8064896" cy="779701"/>
+            <a:off x="6685572" y="3056504"/>
+            <a:ext cx="12419196" cy="933589"/>
           </a:xfrm>
           <a:prstGeom prst="rect">
             <a:avLst/>
@@ -4418,10 +4418,10 @@
               <a:buSzPts val="4800"/>
             </a:pPr>
             <a:r>
-              <a:rPr lang="pt-BR" sz="4400" b="1" dirty="0" smtClean="0"/>
+              <a:rPr lang="pt-BR" sz="5400" b="1" dirty="0" smtClean="0"/>
               <a:t>REQUISITOS FUNCIONAIS</a:t>
             </a:r>
-            <a:endParaRPr lang="pt-BR" sz="4400" b="0" i="0" u="none" strike="noStrike" cap="none" dirty="0">
+            <a:endParaRPr lang="pt-BR" sz="5400" b="0" i="0" u="none" strike="noStrike" cap="none" dirty="0">
               <a:solidFill>
                 <a:srgbClr val="000000"/>
               </a:solidFill>
@@ -5092,8 +5092,8 @@
         </p:nvSpPr>
         <p:spPr>
           <a:xfrm>
-            <a:off x="1265053" y="3185592"/>
-            <a:ext cx="18549281" cy="841256"/>
+            <a:off x="1265053" y="3139426"/>
+            <a:ext cx="18549281" cy="933589"/>
           </a:xfrm>
           <a:prstGeom prst="rect">
             <a:avLst/>
@@ -5113,7 +5113,7 @@
               <a:buSzPts val="4800"/>
             </a:pPr>
             <a:r>
-              <a:rPr lang="pt-BR" sz="4800" b="0" i="0" u="none" strike="noStrike" cap="none" dirty="0" smtClean="0">
+              <a:rPr lang="pt-BR" sz="5400" b="1" i="0" u="none" strike="noStrike" cap="none" dirty="0" smtClean="0">
                 <a:solidFill>
                   <a:srgbClr val="000000"/>
                 </a:solidFill>
@@ -5124,7 +5124,7 @@
               </a:rPr>
               <a:t>DIAGRAMA DE CASO DE USO</a:t>
             </a:r>
-            <a:endParaRPr lang="pt-BR" sz="4800" b="0" i="0" u="none" strike="noStrike" cap="none" dirty="0">
+            <a:endParaRPr lang="pt-BR" sz="5400" b="1" i="0" u="none" strike="noStrike" cap="none" dirty="0">
               <a:solidFill>
                 <a:srgbClr val="000000"/>
               </a:solidFill>
@@ -5144,8 +5144,8 @@
         </p:nvSpPr>
         <p:spPr>
           <a:xfrm>
-            <a:off x="1246913" y="6785992"/>
-            <a:ext cx="18549281" cy="841256"/>
+            <a:off x="1246913" y="7650088"/>
+            <a:ext cx="18549281" cy="933589"/>
           </a:xfrm>
           <a:prstGeom prst="rect">
             <a:avLst/>
@@ -5165,7 +5165,7 @@
               <a:buSzPts val="4800"/>
             </a:pPr>
             <a:r>
-              <a:rPr lang="pt-BR" sz="4800" b="0" i="0" u="none" strike="noStrike" cap="none" dirty="0" smtClean="0">
+              <a:rPr lang="pt-BR" sz="5400" b="1" i="0" u="none" strike="noStrike" cap="none" dirty="0" smtClean="0">
                 <a:solidFill>
                   <a:srgbClr val="000000"/>
                 </a:solidFill>
@@ -5176,7 +5176,7 @@
               </a:rPr>
               <a:t>DIAGRAMA DE PACOTE</a:t>
             </a:r>
-            <a:endParaRPr lang="pt-BR" sz="4800" b="0" i="0" u="none" strike="noStrike" cap="none" dirty="0">
+            <a:endParaRPr lang="pt-BR" sz="5400" b="1" i="0" u="none" strike="noStrike" cap="none" dirty="0">
               <a:solidFill>
                 <a:srgbClr val="000000"/>
               </a:solidFill>
@@ -5233,8 +5233,8 @@
         </p:nvSpPr>
         <p:spPr>
           <a:xfrm>
-            <a:off x="1265053" y="3185592"/>
-            <a:ext cx="18549281" cy="841256"/>
+            <a:off x="1265053" y="3139426"/>
+            <a:ext cx="18549281" cy="933589"/>
           </a:xfrm>
           <a:prstGeom prst="rect">
             <a:avLst/>
@@ -5254,7 +5254,7 @@
               <a:buSzPts val="4800"/>
             </a:pPr>
             <a:r>
-              <a:rPr lang="pt-BR" sz="4800" b="0" i="0" u="none" strike="noStrike" cap="none" dirty="0" smtClean="0">
+              <a:rPr lang="pt-BR" sz="5400" b="1" i="0" u="none" strike="noStrike" cap="none" dirty="0" smtClean="0">
                 <a:solidFill>
                   <a:srgbClr val="000000"/>
                 </a:solidFill>
@@ -5265,7 +5265,7 @@
               </a:rPr>
               <a:t>DIAGRAMA DE CLASSES</a:t>
             </a:r>
-            <a:endParaRPr lang="pt-BR" sz="4800" b="0" i="0" u="none" strike="noStrike" cap="none" dirty="0">
+            <a:endParaRPr lang="pt-BR" sz="5400" b="1" i="0" u="none" strike="noStrike" cap="none" dirty="0">
               <a:solidFill>
                 <a:srgbClr val="000000"/>
               </a:solidFill>
@@ -5285,8 +5285,8 @@
         </p:nvSpPr>
         <p:spPr>
           <a:xfrm>
-            <a:off x="1246913" y="6785992"/>
-            <a:ext cx="18549281" cy="841256"/>
+            <a:off x="1246913" y="7724611"/>
+            <a:ext cx="18549281" cy="933589"/>
           </a:xfrm>
           <a:prstGeom prst="rect">
             <a:avLst/>
@@ -5306,7 +5306,7 @@
               <a:buSzPts val="4800"/>
             </a:pPr>
             <a:r>
-              <a:rPr lang="pt-BR" sz="4800" b="0" i="0" u="none" strike="noStrike" cap="none" dirty="0" smtClean="0">
+              <a:rPr lang="pt-BR" sz="5400" b="1" i="0" u="none" strike="noStrike" cap="none" dirty="0" smtClean="0">
                 <a:solidFill>
                   <a:srgbClr val="000000"/>
                 </a:solidFill>
@@ -5317,7 +5317,7 @@
               </a:rPr>
               <a:t>DIAGRAMA DE SEQUÊNCIA</a:t>
             </a:r>
-            <a:endParaRPr lang="pt-BR" sz="4800" b="0" i="0" u="none" strike="noStrike" cap="none" dirty="0">
+            <a:endParaRPr lang="pt-BR" sz="5400" b="1" i="0" u="none" strike="noStrike" cap="none" dirty="0">
               <a:solidFill>
                 <a:srgbClr val="000000"/>
               </a:solidFill>
@@ -5914,11 +5914,7 @@
             </a:pPr>
             <a:r>
               <a:rPr lang="pt-BR" sz="4800" b="1" dirty="0" smtClean="0"/>
-              <a:t>Elder </a:t>
-            </a:r>
-            <a:r>
-              <a:rPr lang="pt-BR" sz="4800" b="1" dirty="0" smtClean="0"/>
-              <a:t>Connect </a:t>
+              <a:t>Elder Connect </a:t>
             </a:r>
             <a:r>
               <a:rPr lang="pt-BR" sz="4800" b="1" dirty="0"/>
@@ -6538,18 +6534,30 @@
             <a:endParaRPr lang="pt-BR" sz="4800" b="1" dirty="0"/>
           </a:p>
           <a:p>
+            <a:pPr marL="685800" indent="-685800">
+              <a:buFont typeface="Arial" pitchFamily="34" charset="0"/>
+              <a:buChar char="•"/>
+            </a:pPr>
             <a:r>
               <a:rPr lang="pt-BR" sz="4800" b="1" dirty="0"/>
               <a:t>Conexão.</a:t>
             </a:r>
           </a:p>
           <a:p>
+            <a:pPr marL="685800" indent="-685800">
+              <a:buFont typeface="Arial" pitchFamily="34" charset="0"/>
+              <a:buChar char="•"/>
+            </a:pPr>
             <a:r>
               <a:rPr lang="pt-BR" sz="4800" b="1" dirty="0"/>
               <a:t>Gerenciamento.</a:t>
             </a:r>
           </a:p>
           <a:p>
+            <a:pPr marL="685800" indent="-685800">
+              <a:buFont typeface="Arial" pitchFamily="34" charset="0"/>
+              <a:buChar char="•"/>
+            </a:pPr>
             <a:r>
               <a:rPr lang="pt-BR" sz="4800" b="1" dirty="0"/>
               <a:t>Organização do cuidado.</a:t>
@@ -6727,30 +6735,50 @@
           </a:bodyPr>
           <a:lstStyle/>
           <a:p>
+            <a:pPr marL="685800" indent="-685800">
+              <a:buFont typeface="Arial" pitchFamily="34" charset="0"/>
+              <a:buChar char="•"/>
+            </a:pPr>
             <a:r>
               <a:rPr lang="pt-BR" sz="4800" b="1" dirty="0"/>
               <a:t>Cadastro.</a:t>
             </a:r>
           </a:p>
           <a:p>
+            <a:pPr marL="685800" indent="-685800">
+              <a:buFont typeface="Arial" pitchFamily="34" charset="0"/>
+              <a:buChar char="•"/>
+            </a:pPr>
             <a:r>
               <a:rPr lang="pt-BR" sz="4800" b="1" dirty="0"/>
               <a:t>Busca.</a:t>
             </a:r>
           </a:p>
           <a:p>
+            <a:pPr marL="685800" indent="-685800">
+              <a:buFont typeface="Arial" pitchFamily="34" charset="0"/>
+              <a:buChar char="•"/>
+            </a:pPr>
             <a:r>
               <a:rPr lang="pt-BR" sz="4800" b="1" dirty="0"/>
               <a:t>Vínculo.</a:t>
             </a:r>
           </a:p>
           <a:p>
+            <a:pPr marL="685800" indent="-685800">
+              <a:buFont typeface="Arial" pitchFamily="34" charset="0"/>
+              <a:buChar char="•"/>
+            </a:pPr>
             <a:r>
               <a:rPr lang="pt-BR" sz="4800" b="1" dirty="0"/>
               <a:t>Medicamentos.</a:t>
             </a:r>
           </a:p>
           <a:p>
+            <a:pPr marL="685800" indent="-685800">
+              <a:buFont typeface="Arial" pitchFamily="34" charset="0"/>
+              <a:buChar char="•"/>
+            </a:pPr>
             <a:r>
               <a:rPr lang="pt-BR" sz="4800" b="1" dirty="0"/>
               <a:t>Comunicação.</a:t>
@@ -6926,7 +6954,7 @@
         </p:blipFill>
         <p:spPr bwMode="auto">
           <a:xfrm>
-            <a:off x="8441804" y="9147128"/>
+            <a:off x="6350542" y="8970198"/>
             <a:ext cx="2419350" cy="1609725"/>
           </a:xfrm>
           <a:prstGeom prst="rect">
@@ -6967,7 +6995,7 @@
         </p:blipFill>
         <p:spPr bwMode="auto">
           <a:xfrm>
-            <a:off x="5345461" y="8919110"/>
+            <a:off x="14287276" y="5247722"/>
             <a:ext cx="1752600" cy="1752600"/>
           </a:xfrm>
           <a:prstGeom prst="rect">
@@ -7008,7 +7036,7 @@
         </p:blipFill>
         <p:spPr bwMode="auto">
           <a:xfrm>
-            <a:off x="15519473" y="9116852"/>
+            <a:off x="17574692" y="8701842"/>
             <a:ext cx="1952625" cy="1952625"/>
           </a:xfrm>
           <a:prstGeom prst="rect">
@@ -7049,7 +7077,7 @@
         </p:blipFill>
         <p:spPr bwMode="auto">
           <a:xfrm>
-            <a:off x="12509445" y="5497328"/>
+            <a:off x="10432830" y="5506906"/>
             <a:ext cx="1352550" cy="1352550"/>
           </a:xfrm>
           <a:prstGeom prst="rect">
@@ -7090,7 +7118,7 @@
         </p:blipFill>
         <p:spPr bwMode="auto">
           <a:xfrm>
-            <a:off x="8076676" y="5302066"/>
+            <a:off x="6688680" y="5165491"/>
             <a:ext cx="1743075" cy="1743075"/>
           </a:xfrm>
           <a:prstGeom prst="rect">
@@ -7131,7 +7159,7 @@
         </p:blipFill>
         <p:spPr bwMode="auto">
           <a:xfrm>
-            <a:off x="2398913" y="5115462"/>
+            <a:off x="1894856" y="5028917"/>
             <a:ext cx="2016224" cy="2016224"/>
           </a:xfrm>
           <a:prstGeom prst="rect">
@@ -7172,7 +7200,7 @@
         </p:blipFill>
         <p:spPr bwMode="auto">
           <a:xfrm>
-            <a:off x="12042204" y="9137603"/>
+            <a:off x="14420626" y="8864571"/>
             <a:ext cx="1619250" cy="1619250"/>
           </a:xfrm>
           <a:prstGeom prst="rect">
@@ -7250,6 +7278,129 @@
                   </a:outerShdw>
                 </a:effectLst>
               </a14:hiddenEffects>
+            </a:ext>
+          </a:extLst>
+        </p:spPr>
+      </p:pic>
+      <p:pic>
+        <p:nvPicPr>
+          <p:cNvPr id="4" name="Picture 3" descr="C:\Users\Junior\Downloads\postgre (1).png"/>
+          <p:cNvPicPr>
+            <a:picLocks noChangeAspect="1" noChangeArrowheads="1"/>
+          </p:cNvPicPr>
+          <p:nvPr/>
+        </p:nvPicPr>
+        <p:blipFill>
+          <a:blip r:embed="rId11">
+            <a:extLst>
+              <a:ext uri="{28A0092B-C50C-407E-A947-70E740481C1C}">
+                <a14:useLocalDpi xmlns:a14="http://schemas.microsoft.com/office/drawing/2010/main" val="0"/>
+              </a:ext>
+            </a:extLst>
+          </a:blip>
+          <a:srcRect/>
+          <a:stretch>
+            <a:fillRect/>
+          </a:stretch>
+        </p:blipFill>
+        <p:spPr bwMode="auto">
+          <a:xfrm>
+            <a:off x="17403242" y="5288384"/>
+            <a:ext cx="2124075" cy="1943100"/>
+          </a:xfrm>
+          <a:prstGeom prst="rect">
+            <a:avLst/>
+          </a:prstGeom>
+          <a:noFill/>
+          <a:extLst>
+            <a:ext uri="{909E8E84-426E-40DD-AFC4-6F175D3DCCD1}">
+              <a14:hiddenFill xmlns:a14="http://schemas.microsoft.com/office/drawing/2010/main">
+                <a:solidFill>
+                  <a:srgbClr val="FFFFFF"/>
+                </a:solidFill>
+              </a14:hiddenFill>
+            </a:ext>
+          </a:extLst>
+        </p:spPr>
+      </p:pic>
+      <p:pic>
+        <p:nvPicPr>
+          <p:cNvPr id="5" name="Picture 4" descr="C:\Users\Junior\Downloads\Angular_gradient_logo.png"/>
+          <p:cNvPicPr>
+            <a:picLocks noChangeAspect="1" noChangeArrowheads="1"/>
+          </p:cNvPicPr>
+          <p:nvPr/>
+        </p:nvPicPr>
+        <p:blipFill>
+          <a:blip r:embed="rId12">
+            <a:extLst>
+              <a:ext uri="{28A0092B-C50C-407E-A947-70E740481C1C}">
+                <a14:useLocalDpi xmlns:a14="http://schemas.microsoft.com/office/drawing/2010/main" val="0"/>
+              </a:ext>
+            </a:extLst>
+          </a:blip>
+          <a:srcRect/>
+          <a:stretch>
+            <a:fillRect/>
+          </a:stretch>
+        </p:blipFill>
+        <p:spPr bwMode="auto">
+          <a:xfrm>
+            <a:off x="1894854" y="8705005"/>
+            <a:ext cx="2016225" cy="2016225"/>
+          </a:xfrm>
+          <a:prstGeom prst="rect">
+            <a:avLst/>
+          </a:prstGeom>
+          <a:noFill/>
+          <a:extLst>
+            <a:ext uri="{909E8E84-426E-40DD-AFC4-6F175D3DCCD1}">
+              <a14:hiddenFill xmlns:a14="http://schemas.microsoft.com/office/drawing/2010/main">
+                <a:solidFill>
+                  <a:srgbClr val="FFFFFF"/>
+                </a:solidFill>
+              </a14:hiddenFill>
+            </a:ext>
+          </a:extLst>
+        </p:spPr>
+      </p:pic>
+      <p:pic>
+        <p:nvPicPr>
+          <p:cNvPr id="6" name="Picture 5" descr="C:\Users\Junior\Downloads\vs code.png"/>
+          <p:cNvPicPr>
+            <a:picLocks noChangeAspect="1" noChangeArrowheads="1"/>
+          </p:cNvPicPr>
+          <p:nvPr/>
+        </p:nvPicPr>
+        <p:blipFill>
+          <a:blip r:embed="rId13">
+            <a:extLst>
+              <a:ext uri="{28A0092B-C50C-407E-A947-70E740481C1C}">
+                <a14:useLocalDpi xmlns:a14="http://schemas.microsoft.com/office/drawing/2010/main" val="0"/>
+              </a:ext>
+            </a:extLst>
+          </a:blip>
+          <a:srcRect/>
+          <a:stretch>
+            <a:fillRect/>
+          </a:stretch>
+        </p:blipFill>
+        <p:spPr bwMode="auto">
+          <a:xfrm>
+            <a:off x="10514498" y="9030866"/>
+            <a:ext cx="1270882" cy="1270882"/>
+          </a:xfrm>
+          <a:prstGeom prst="rect">
+            <a:avLst/>
+          </a:prstGeom>
+          <a:noFill/>
+          <a:extLst>
+            <a:ext uri="{909E8E84-426E-40DD-AFC4-6F175D3DCCD1}">
+              <a14:hiddenFill xmlns:a14="http://schemas.microsoft.com/office/drawing/2010/main">
+                <a:solidFill>
+                  <a:srgbClr val="FFFFFF"/>
+                </a:solidFill>
+              </a14:hiddenFill>
             </a:ext>
           </a:extLst>
         </p:spPr>
@@ -7299,8 +7450,8 @@
         </p:nvSpPr>
         <p:spPr>
           <a:xfrm>
-            <a:off x="1291996" y="3033772"/>
-            <a:ext cx="18549281" cy="841256"/>
+            <a:off x="1291996" y="2987606"/>
+            <a:ext cx="18549281" cy="933589"/>
           </a:xfrm>
           <a:prstGeom prst="rect">
             <a:avLst/>
@@ -7320,10 +7471,10 @@
               <a:buSzPts val="4800"/>
             </a:pPr>
             <a:r>
-              <a:rPr lang="pt-BR" sz="4800" b="1" dirty="0" smtClean="0"/>
+              <a:rPr lang="pt-BR" sz="5400" b="1" dirty="0" smtClean="0"/>
               <a:t>METODOLOGIA</a:t>
             </a:r>
-            <a:endParaRPr lang="pt-BR" sz="4800" b="0" i="0" u="none" strike="noStrike" cap="none" dirty="0">
+            <a:endParaRPr lang="pt-BR" sz="5400" b="0" i="0" u="none" strike="noStrike" cap="none" dirty="0">
               <a:solidFill>
                 <a:srgbClr val="000000"/>
               </a:solidFill>
@@ -7343,7 +7494,7 @@
         </p:nvSpPr>
         <p:spPr>
           <a:xfrm>
-            <a:off x="1464728" y="4813901"/>
+            <a:off x="1291995" y="5057800"/>
             <a:ext cx="18549281" cy="3057247"/>
           </a:xfrm>
           <a:prstGeom prst="rect">
@@ -7360,31 +7511,88 @@
           </a:bodyPr>
           <a:lstStyle/>
           <a:p>
-            <a:r>
-              <a:rPr lang="pt-BR" sz="4800" dirty="0"/>
+            <a:pPr marL="685800" indent="-685800">
+              <a:buFont typeface="Arial" pitchFamily="34" charset="0"/>
+              <a:buChar char="•"/>
+            </a:pPr>
+            <a:r>
+              <a:rPr lang="pt-BR" sz="4800" b="1" dirty="0"/>
               <a:t>Levantamento de requisitos.</a:t>
             </a:r>
           </a:p>
           <a:p>
-            <a:r>
-              <a:rPr lang="pt-BR" sz="4800" dirty="0"/>
+            <a:pPr marL="685800" indent="-685800">
+              <a:buFont typeface="Arial" pitchFamily="34" charset="0"/>
+              <a:buChar char="•"/>
+            </a:pPr>
+            <a:r>
+              <a:rPr lang="pt-BR" sz="4800" b="1" dirty="0"/>
               <a:t>Entrevistas.</a:t>
             </a:r>
           </a:p>
           <a:p>
-            <a:r>
-              <a:rPr lang="pt-BR" sz="4800" dirty="0"/>
+            <a:pPr marL="685800" indent="-685800">
+              <a:buFont typeface="Arial" pitchFamily="34" charset="0"/>
+              <a:buChar char="•"/>
+            </a:pPr>
+            <a:r>
+              <a:rPr lang="pt-BR" sz="4800" b="1" dirty="0"/>
               <a:t>Análise.</a:t>
             </a:r>
           </a:p>
           <a:p>
-            <a:r>
-              <a:rPr lang="pt-BR" sz="4800" dirty="0"/>
+            <a:pPr marL="685800" indent="-685800">
+              <a:buFont typeface="Arial" pitchFamily="34" charset="0"/>
+              <a:buChar char="•"/>
+            </a:pPr>
+            <a:r>
+              <a:rPr lang="pt-BR" sz="4800" b="1" dirty="0"/>
               <a:t>Modelagem.</a:t>
             </a:r>
           </a:p>
         </p:txBody>
       </p:sp>
+      <p:pic>
+        <p:nvPicPr>
+          <p:cNvPr id="2051" name="Picture 3" descr="C:\Users\Junior\Downloads\check list (1).png"/>
+          <p:cNvPicPr>
+            <a:picLocks noChangeAspect="1" noChangeArrowheads="1"/>
+          </p:cNvPicPr>
+          <p:nvPr/>
+        </p:nvPicPr>
+        <p:blipFill>
+          <a:blip r:embed="rId3">
+            <a:extLst>
+              <a:ext uri="{28A0092B-C50C-407E-A947-70E740481C1C}">
+                <a14:useLocalDpi xmlns:a14="http://schemas.microsoft.com/office/drawing/2010/main" val="0"/>
+              </a:ext>
+            </a:extLst>
+          </a:blip>
+          <a:srcRect/>
+          <a:stretch>
+            <a:fillRect/>
+          </a:stretch>
+        </p:blipFill>
+        <p:spPr bwMode="auto">
+          <a:xfrm>
+            <a:off x="13992200" y="3862063"/>
+            <a:ext cx="5396433" cy="6380313"/>
+          </a:xfrm>
+          <a:prstGeom prst="rect">
+            <a:avLst/>
+          </a:prstGeom>
+          <a:noFill/>
+          <a:extLst>
+            <a:ext uri="{909E8E84-426E-40DD-AFC4-6F175D3DCCD1}">
+              <a14:hiddenFill xmlns:a14="http://schemas.microsoft.com/office/drawing/2010/main">
+                <a:solidFill>
+                  <a:srgbClr val="FFFFFF"/>
+                </a:solidFill>
+              </a14:hiddenFill>
+            </a:ext>
+          </a:extLst>
+        </p:spPr>
+      </p:pic>
     </p:spTree>
     <p:extLst>
       <p:ext uri="{BB962C8B-B14F-4D97-AF65-F5344CB8AC3E}">
@@ -7430,8 +7638,8 @@
         </p:nvSpPr>
         <p:spPr>
           <a:xfrm>
-            <a:off x="6791400" y="2512444"/>
-            <a:ext cx="8352928" cy="1764586"/>
+            <a:off x="6791400" y="2927942"/>
+            <a:ext cx="10945216" cy="933589"/>
           </a:xfrm>
           <a:prstGeom prst="rect">
             <a:avLst/>

</xml_diff>

<commit_message>
docs: remocao de slide vazio
</commit_message>
<xml_diff>
--- a/Apresentacao/Faitec_2026_EldeConnect-Rev.pptx
+++ b/Apresentacao/Faitec_2026_EldeConnect-Rev.pptx
@@ -5,7 +5,7 @@
     <p:sldMasterId id="2147483648" r:id="rId1"/>
   </p:sldMasterIdLst>
   <p:notesMasterIdLst>
-    <p:notesMasterId r:id="rId21"/>
+    <p:notesMasterId r:id="rId20"/>
   </p:notesMasterIdLst>
   <p:sldIdLst>
     <p:sldId id="256" r:id="rId2"/>
@@ -25,25 +25,24 @@
     <p:sldId id="272" r:id="rId16"/>
     <p:sldId id="258" r:id="rId17"/>
     <p:sldId id="273" r:id="rId18"/>
-    <p:sldId id="274" r:id="rId19"/>
-    <p:sldId id="259" r:id="rId20"/>
+    <p:sldId id="259" r:id="rId19"/>
   </p:sldIdLst>
   <p:sldSz cx="24384000" cy="13716000"/>
   <p:notesSz cx="6858000" cy="9144000"/>
   <p:embeddedFontLst>
     <p:embeddedFont>
-      <p:font typeface="Helvetica Neue" charset="0"/>
-      <p:regular r:id="rId22"/>
-      <p:bold r:id="rId23"/>
-      <p:italic r:id="rId24"/>
-      <p:boldItalic r:id="rId25"/>
+      <p:font typeface="Helvetica Neue" panose="020B0604020202020204" charset="0"/>
+      <p:regular r:id="rId21"/>
+      <p:bold r:id="rId22"/>
+      <p:italic r:id="rId23"/>
+      <p:boldItalic r:id="rId24"/>
     </p:embeddedFont>
     <p:embeddedFont>
-      <p:font typeface="Helvetica Neue Light" charset="0"/>
-      <p:regular r:id="rId26"/>
-      <p:bold r:id="rId27"/>
-      <p:italic r:id="rId28"/>
-      <p:boldItalic r:id="rId29"/>
+      <p:font typeface="Helvetica Neue Light" panose="020B0604020202020204" charset="0"/>
+      <p:regular r:id="rId25"/>
+      <p:bold r:id="rId26"/>
+      <p:italic r:id="rId27"/>
+      <p:boldItalic r:id="rId28"/>
     </p:embeddedFont>
   </p:embeddedFontLst>
   <p:defaultTextStyle>
@@ -276,8 +275,22 @@
     </a:lvl9pPr>
   </p:defaultTextStyle>
   <p:extLst>
+    <p:ext uri="{EFAFB233-063F-42B5-8137-9DF3F51BA10A}">
+      <p15:sldGuideLst xmlns:p15="http://schemas.microsoft.com/office/powerpoint/2012/main">
+        <p15:guide id="1" orient="horz" pos="4320">
+          <p15:clr>
+            <a:srgbClr val="A4A3A4"/>
+          </p15:clr>
+        </p15:guide>
+        <p15:guide id="2" pos="7680">
+          <p15:clr>
+            <a:srgbClr val="A4A3A4"/>
+          </p15:clr>
+        </p15:guide>
+      </p15:sldGuideLst>
+    </p:ext>
     <p:ext uri="GoogleSlidesCustomDataVersion2">
-      <go:slidesCustomData xmlns:go="http://customooxmlschemas.google.com/" xmlns:ahyp="http://schemas.microsoft.com/office/drawing/2018/hyperlinkcolor" xmlns:p15="http://schemas.microsoft.com/office/powerpoint/2012/main" xmlns:p14="http://schemas.microsoft.com/office/powerpoint/2010/main" xmlns:com="http://schemas.openxmlformats.org/drawingml/2006/compatibility" xmlns:pvml="urn:schemas-microsoft-com:office:powerpoint" xmlns:v="urn:schemas-microsoft-com:vml" xmlns:o="urn:schemas-microsoft-com:office:office" xmlns:dgm="http://schemas.openxmlformats.org/drawingml/2006/diagram" xmlns:c="http://schemas.openxmlformats.org/drawingml/2006/chart" xmlns:mv="urn:schemas-microsoft-com:mac:vml" xmlns:mc="http://schemas.openxmlformats.org/markup-compatibility/2006" xmlns="" r:id="rId30" roundtripDataSignature="AMtx7mgZ84KggsQfQCuyVjL79bhoOGuyfA=="/>
+      <go:slidesCustomData xmlns="" xmlns:mc="http://schemas.openxmlformats.org/markup-compatibility/2006" xmlns:mv="urn:schemas-microsoft-com:mac:vml" xmlns:c="http://schemas.openxmlformats.org/drawingml/2006/chart" xmlns:dgm="http://schemas.openxmlformats.org/drawingml/2006/diagram" xmlns:o="urn:schemas-microsoft-com:office:office" xmlns:v="urn:schemas-microsoft-com:vml" xmlns:pvml="urn:schemas-microsoft-com:office:powerpoint" xmlns:com="http://schemas.openxmlformats.org/drawingml/2006/compatibility" xmlns:p14="http://schemas.microsoft.com/office/powerpoint/2010/main" xmlns:p15="http://schemas.microsoft.com/office/powerpoint/2012/main" xmlns:ahyp="http://schemas.microsoft.com/office/drawing/2018/hyperlinkcolor" xmlns:go="http://customooxmlschemas.google.com/" r:id="rId30" roundtripDataSignature="AMtx7mgZ84KggsQfQCuyVjL79bhoOGuyfA=="/>
     </p:ext>
   </p:extLst>
 </p:presentation>
@@ -4040,7 +4053,7 @@
               <a:buChar char="•"/>
             </a:pPr>
             <a:r>
-              <a:rPr lang="en-US" sz="4300" dirty="0" smtClean="0">
+              <a:rPr lang="en-US" sz="4300" dirty="0">
                 <a:latin typeface="Helvetica Neue"/>
                 <a:ea typeface="Helvetica Neue"/>
                 <a:cs typeface="Helvetica Neue"/>
@@ -4065,18 +4078,6 @@
               </a:buClr>
               <a:buSzPts val="5375"/>
             </a:pPr>
-            <a:r>
-              <a:rPr lang="en-US" sz="4300" b="0" i="0" u="none" strike="noStrike" cap="none" dirty="0">
-                <a:solidFill>
-                  <a:srgbClr val="000000"/>
-                </a:solidFill>
-                <a:latin typeface="Helvetica Neue"/>
-                <a:ea typeface="Helvetica Neue"/>
-                <a:cs typeface="Helvetica Neue"/>
-                <a:sym typeface="Helvetica Neue"/>
-              </a:rPr>
-              <a:t/>
-            </a:r>
             <a:br>
               <a:rPr lang="en-US" sz="4300" b="0" i="0" u="none" strike="noStrike" cap="none" dirty="0">
                 <a:solidFill>
@@ -4089,7 +4090,7 @@
               </a:rPr>
             </a:br>
             <a:r>
-              <a:rPr lang="en-US" sz="4300" dirty="0" smtClean="0">
+              <a:rPr lang="en-US" sz="4300" dirty="0">
                 <a:latin typeface="Helvetica Neue"/>
                 <a:ea typeface="Helvetica Neue"/>
                 <a:cs typeface="Helvetica Neue"/>
@@ -4115,7 +4116,7 @@
               <a:buSzPts val="5375"/>
             </a:pPr>
             <a:r>
-              <a:rPr lang="en-US" sz="4300" dirty="0" smtClean="0">
+              <a:rPr lang="en-US" sz="4300" dirty="0">
                 <a:latin typeface="Helvetica Neue"/>
                 <a:sym typeface="Helvetica Neue"/>
               </a:rPr>
@@ -4139,7 +4140,7 @@
               <a:buSzPts val="5375"/>
             </a:pPr>
             <a:r>
-              <a:rPr lang="en-US" sz="4300" dirty="0" smtClean="0">
+              <a:rPr lang="en-US" sz="4300" dirty="0">
                 <a:latin typeface="Helvetica Neue"/>
                 <a:sym typeface="Helvetica Neue"/>
               </a:rPr>
@@ -4154,13 +4155,6 @@
   <p:clrMapOvr>
     <a:masterClrMapping/>
   </p:clrMapOvr>
-  <p:timing>
-    <p:tnLst>
-      <p:par>
-        <p:cTn id="1" dur="indefinite" restart="never" nodeType="tmRoot"/>
-      </p:par>
-    </p:tnLst>
-  </p:timing>
 </p:sld>
 </file>
 
@@ -4210,7 +4204,7 @@
               <a:buSzPts val="4800"/>
             </a:pPr>
             <a:r>
-              <a:rPr lang="pt-BR" sz="5400" b="1" dirty="0" smtClean="0"/>
+              <a:rPr lang="pt-BR" sz="5400" b="1" dirty="0"/>
               <a:t>REQUISITOS FUNCIONAIS</a:t>
             </a:r>
             <a:endParaRPr lang="pt-BR" sz="5400" b="0" i="0" u="none" strike="noStrike" cap="none" dirty="0">
@@ -4252,11 +4246,7 @@
           <a:p>
             <a:r>
               <a:rPr lang="pt-BR" sz="4800" b="1" dirty="0"/>
-              <a:t>Módulo – Gestão de </a:t>
-            </a:r>
-            <a:r>
-              <a:rPr lang="pt-BR" sz="4800" b="1" dirty="0" smtClean="0"/>
-              <a:t>Cuidadores</a:t>
+              <a:t>Módulo – Gestão de Cuidadores</a:t>
             </a:r>
           </a:p>
           <a:p>
@@ -4362,13 +4352,6 @@
   <p:clrMapOvr>
     <a:masterClrMapping/>
   </p:clrMapOvr>
-  <p:timing>
-    <p:tnLst>
-      <p:par>
-        <p:cTn id="1" dur="indefinite" restart="never" nodeType="tmRoot"/>
-      </p:par>
-    </p:tnLst>
-  </p:timing>
 </p:sld>
 </file>
 
@@ -4418,7 +4401,7 @@
               <a:buSzPts val="4800"/>
             </a:pPr>
             <a:r>
-              <a:rPr lang="pt-BR" sz="4400" b="1" dirty="0" smtClean="0"/>
+              <a:rPr lang="pt-BR" sz="4400" b="1" dirty="0"/>
               <a:t>REQUISITOS FUNCIONAIS</a:t>
             </a:r>
             <a:endParaRPr lang="pt-BR" sz="4400" b="0" i="0" u="none" strike="noStrike" cap="none" dirty="0">
@@ -4460,14 +4443,10 @@
           <a:p>
             <a:r>
               <a:rPr lang="pt-BR" sz="4800" b="1" dirty="0"/>
-              <a:t>Módulo – Gestão de </a:t>
-            </a:r>
-            <a:r>
-              <a:rPr lang="pt-BR" sz="4800" b="1" dirty="0" smtClean="0"/>
-              <a:t>Relacionamento</a:t>
+              <a:t>Módulo – Gestão de Relacionamento</a:t>
             </a:r>
             <a:br>
-              <a:rPr lang="pt-BR" sz="4800" b="1" dirty="0" smtClean="0"/>
+              <a:rPr lang="pt-BR" sz="4800" b="1" dirty="0"/>
             </a:br>
             <a:endParaRPr lang="pt-BR" sz="4800" b="1" dirty="0"/>
           </a:p>
@@ -4480,32 +4459,20 @@
           <a:p>
             <a:r>
               <a:rPr lang="pt-BR" sz="4800" b="1" dirty="0"/>
-              <a:t>RF 12 – Finalizar vínculo / contrato entre cuidador e </a:t>
-            </a:r>
-            <a:r>
-              <a:rPr lang="pt-BR" sz="4800" b="1" dirty="0" smtClean="0"/>
-              <a:t>idoso</a:t>
+              <a:t>RF 12 – Finalizar vínculo / contrato entre cuidador e idoso</a:t>
             </a:r>
             <a:br>
-              <a:rPr lang="pt-BR" sz="4800" b="1" dirty="0" smtClean="0"/>
+              <a:rPr lang="pt-BR" sz="4800" b="1" dirty="0"/>
             </a:br>
-            <a:r>
-              <a:rPr lang="pt-BR" sz="4800" b="1" dirty="0" smtClean="0"/>
-              <a:t/>
-            </a:r>
             <a:br>
-              <a:rPr lang="pt-BR" sz="4800" b="1" dirty="0" smtClean="0"/>
+              <a:rPr lang="pt-BR" sz="4800" b="1" dirty="0"/>
             </a:br>
             <a:r>
               <a:rPr lang="pt-BR" sz="4800" b="1" dirty="0"/>
-              <a:t>Módulo – Gestão de </a:t>
-            </a:r>
-            <a:r>
-              <a:rPr lang="pt-BR" sz="4800" b="1" dirty="0" smtClean="0"/>
-              <a:t>Saúde</a:t>
+              <a:t>Módulo – Gestão de Saúde</a:t>
             </a:r>
             <a:br>
-              <a:rPr lang="pt-BR" sz="4800" b="1" dirty="0" smtClean="0"/>
+              <a:rPr lang="pt-BR" sz="4800" b="1" dirty="0"/>
             </a:br>
             <a:endParaRPr lang="pt-BR" sz="4800" b="1" dirty="0"/>
           </a:p>
@@ -4594,13 +4561,6 @@
   <p:clrMapOvr>
     <a:masterClrMapping/>
   </p:clrMapOvr>
-  <p:timing>
-    <p:tnLst>
-      <p:par>
-        <p:cTn id="1" dur="indefinite" restart="never" nodeType="tmRoot"/>
-      </p:par>
-    </p:tnLst>
-  </p:timing>
 </p:sld>
 </file>
 
@@ -4770,13 +4730,6 @@
   <p:clrMapOvr>
     <a:masterClrMapping/>
   </p:clrMapOvr>
-  <p:timing>
-    <p:tnLst>
-      <p:par>
-        <p:cTn id="1" dur="indefinite" restart="never" nodeType="tmRoot"/>
-      </p:par>
-    </p:tnLst>
-  </p:timing>
 </p:sld>
 </file>
 
@@ -4832,14 +4785,10 @@
             </a:r>
             <a:r>
               <a:rPr lang="pt-BR" sz="4800" dirty="0"/>
-              <a:t> e Minimização de Dados</a:t>
-            </a:r>
-            <a:r>
-              <a:rPr lang="pt-BR" sz="4800" dirty="0" smtClean="0"/>
-              <a:t>:</a:t>
+              <a:t> e Minimização de Dados:</a:t>
             </a:r>
             <a:br>
-              <a:rPr lang="pt-BR" sz="4800" dirty="0" smtClean="0"/>
+              <a:rPr lang="pt-BR" sz="4800" dirty="0"/>
             </a:br>
             <a:endParaRPr lang="pt-BR" sz="4800" dirty="0"/>
           </a:p>
@@ -4862,13 +4811,6 @@
   <p:clrMapOvr>
     <a:masterClrMapping/>
   </p:clrMapOvr>
-  <p:timing>
-    <p:tnLst>
-      <p:par>
-        <p:cTn id="1" dur="indefinite" restart="never" nodeType="tmRoot"/>
-      </p:par>
-    </p:tnLst>
-  </p:timing>
 </p:sld>
 </file>
 
@@ -4920,11 +4862,7 @@
             </a:pPr>
             <a:r>
               <a:rPr lang="pt-BR" sz="4800" dirty="0"/>
-              <a:t>Direito de Exclusão e Revogação (Direito ao Esquecimento</a:t>
-            </a:r>
-            <a:r>
-              <a:rPr lang="pt-BR" sz="4800" dirty="0" smtClean="0"/>
-              <a:t>):</a:t>
+              <a:t>Direito de Exclusão e Revogação (Direito ao Esquecimento):</a:t>
             </a:r>
           </a:p>
           <a:p>
@@ -4946,13 +4884,8 @@
             </a:r>
             <a:r>
               <a:rPr lang="pt-BR" sz="4800" dirty="0"/>
-              <a:t> que apagará logicamente (e fisicamente após 30 dias</a:t>
-            </a:r>
-            <a:r>
-              <a:rPr lang="pt-BR" sz="4800" dirty="0" smtClean="0"/>
-              <a:t>).</a:t>
-            </a:r>
-            <a:endParaRPr lang="pt-BR" sz="4800" dirty="0"/>
+              <a:t> que apagará logicamente (e fisicamente após 30 dias).</a:t>
+            </a:r>
           </a:p>
         </p:txBody>
       </p:sp>
@@ -4966,13 +4899,6 @@
   <p:clrMapOvr>
     <a:masterClrMapping/>
   </p:clrMapOvr>
-  <p:timing>
-    <p:tnLst>
-      <p:par>
-        <p:cTn id="1" dur="indefinite" restart="never" nodeType="tmRoot"/>
-      </p:par>
-    </p:tnLst>
-  </p:timing>
 </p:sld>
 </file>
 
@@ -5024,11 +4950,7 @@
             </a:pPr>
             <a:r>
               <a:rPr lang="pt-BR" sz="4800" dirty="0"/>
-              <a:t>Segurança dos Dados de Saúde (Dados Sensíveis</a:t>
-            </a:r>
-            <a:r>
-              <a:rPr lang="pt-BR" sz="4800" dirty="0" smtClean="0"/>
-              <a:t>):</a:t>
+              <a:t>Segurança dos Dados de Saúde (Dados Sensíveis):</a:t>
             </a:r>
           </a:p>
           <a:p>
@@ -5057,13 +4979,6 @@
   <p:clrMapOvr>
     <a:masterClrMapping/>
   </p:clrMapOvr>
-  <p:timing>
-    <p:tnLst>
-      <p:par>
-        <p:cTn id="1" dur="indefinite" restart="never" nodeType="tmRoot"/>
-      </p:par>
-    </p:tnLst>
-  </p:timing>
 </p:sld>
 </file>
 
@@ -5113,7 +5028,7 @@
               <a:buSzPts val="4800"/>
             </a:pPr>
             <a:r>
-              <a:rPr lang="pt-BR" sz="4800" b="0" i="0" u="none" strike="noStrike" cap="none" dirty="0" smtClean="0">
+              <a:rPr lang="pt-BR" sz="4800" b="0" i="0" u="none" strike="noStrike" cap="none" dirty="0">
                 <a:solidFill>
                   <a:srgbClr val="000000"/>
                 </a:solidFill>
@@ -5124,15 +5039,6 @@
               </a:rPr>
               <a:t>DIAGRAMA DE CASO DE USO</a:t>
             </a:r>
-            <a:endParaRPr lang="pt-BR" sz="4800" b="0" i="0" u="none" strike="noStrike" cap="none" dirty="0">
-              <a:solidFill>
-                <a:srgbClr val="000000"/>
-              </a:solidFill>
-              <a:latin typeface="Helvetica Neue"/>
-              <a:ea typeface="Helvetica Neue"/>
-              <a:cs typeface="Helvetica Neue"/>
-              <a:sym typeface="Helvetica Neue"/>
-            </a:endParaRPr>
           </a:p>
         </p:txBody>
       </p:sp>
@@ -5165,7 +5071,7 @@
               <a:buSzPts val="4800"/>
             </a:pPr>
             <a:r>
-              <a:rPr lang="pt-BR" sz="4800" b="0" i="0" u="none" strike="noStrike" cap="none" dirty="0" smtClean="0">
+              <a:rPr lang="pt-BR" sz="4800" b="0" i="0" u="none" strike="noStrike" cap="none" dirty="0">
                 <a:solidFill>
                   <a:srgbClr val="000000"/>
                 </a:solidFill>
@@ -5176,15 +5082,6 @@
               </a:rPr>
               <a:t>DIAGRAMA DE PACOTE</a:t>
             </a:r>
-            <a:endParaRPr lang="pt-BR" sz="4800" b="0" i="0" u="none" strike="noStrike" cap="none" dirty="0">
-              <a:solidFill>
-                <a:srgbClr val="000000"/>
-              </a:solidFill>
-              <a:latin typeface="Helvetica Neue"/>
-              <a:ea typeface="Helvetica Neue"/>
-              <a:cs typeface="Helvetica Neue"/>
-              <a:sym typeface="Helvetica Neue"/>
-            </a:endParaRPr>
           </a:p>
         </p:txBody>
       </p:sp>
@@ -5198,13 +5095,6 @@
   <p:clrMapOvr>
     <a:masterClrMapping/>
   </p:clrMapOvr>
-  <p:timing>
-    <p:tnLst>
-      <p:par>
-        <p:cTn id="1" dur="indefinite" restart="never" nodeType="tmRoot"/>
-      </p:par>
-    </p:tnLst>
-  </p:timing>
 </p:sld>
 </file>
 
@@ -5254,7 +5144,7 @@
               <a:buSzPts val="4800"/>
             </a:pPr>
             <a:r>
-              <a:rPr lang="pt-BR" sz="4800" b="0" i="0" u="none" strike="noStrike" cap="none" dirty="0" smtClean="0">
+              <a:rPr lang="pt-BR" sz="4800" b="0" i="0" u="none" strike="noStrike" cap="none" dirty="0">
                 <a:solidFill>
                   <a:srgbClr val="000000"/>
                 </a:solidFill>
@@ -5265,15 +5155,6 @@
               </a:rPr>
               <a:t>DIAGRAMA DE CLASSES</a:t>
             </a:r>
-            <a:endParaRPr lang="pt-BR" sz="4800" b="0" i="0" u="none" strike="noStrike" cap="none" dirty="0">
-              <a:solidFill>
-                <a:srgbClr val="000000"/>
-              </a:solidFill>
-              <a:latin typeface="Helvetica Neue"/>
-              <a:ea typeface="Helvetica Neue"/>
-              <a:cs typeface="Helvetica Neue"/>
-              <a:sym typeface="Helvetica Neue"/>
-            </a:endParaRPr>
           </a:p>
         </p:txBody>
       </p:sp>
@@ -5306,7 +5187,7 @@
               <a:buSzPts val="4800"/>
             </a:pPr>
             <a:r>
-              <a:rPr lang="pt-BR" sz="4800" b="0" i="0" u="none" strike="noStrike" cap="none" dirty="0" smtClean="0">
+              <a:rPr lang="pt-BR" sz="4800" b="0" i="0" u="none" strike="noStrike" cap="none" dirty="0">
                 <a:solidFill>
                   <a:srgbClr val="000000"/>
                 </a:solidFill>
@@ -5317,15 +5198,6 @@
               </a:rPr>
               <a:t>DIAGRAMA DE SEQUÊNCIA</a:t>
             </a:r>
-            <a:endParaRPr lang="pt-BR" sz="4800" b="0" i="0" u="none" strike="noStrike" cap="none" dirty="0">
-              <a:solidFill>
-                <a:srgbClr val="000000"/>
-              </a:solidFill>
-              <a:latin typeface="Helvetica Neue"/>
-              <a:ea typeface="Helvetica Neue"/>
-              <a:cs typeface="Helvetica Neue"/>
-              <a:sym typeface="Helvetica Neue"/>
-            </a:endParaRPr>
           </a:p>
         </p:txBody>
       </p:sp>
@@ -5339,54 +5211,10 @@
   <p:clrMapOvr>
     <a:masterClrMapping/>
   </p:clrMapOvr>
-  <p:timing>
-    <p:tnLst>
-      <p:par>
-        <p:cTn id="1" dur="indefinite" restart="never" nodeType="tmRoot"/>
-      </p:par>
-    </p:tnLst>
-  </p:timing>
 </p:sld>
 </file>
 
 <file path=ppt/slides/slide18.xml><?xml version="1.0" encoding="utf-8"?>
-<p:sld xmlns:a="http://schemas.openxmlformats.org/drawingml/2006/main" xmlns:r="http://schemas.openxmlformats.org/officeDocument/2006/relationships" xmlns:p="http://schemas.openxmlformats.org/presentationml/2006/main">
-  <p:cSld>
-    <p:spTree>
-      <p:nvGrpSpPr>
-        <p:cNvPr id="1" name=""/>
-        <p:cNvGrpSpPr/>
-        <p:nvPr/>
-      </p:nvGrpSpPr>
-      <p:grpSpPr>
-        <a:xfrm>
-          <a:off x="0" y="0"/>
-          <a:ext cx="0" cy="0"/>
-          <a:chOff x="0" y="0"/>
-          <a:chExt cx="0" cy="0"/>
-        </a:xfrm>
-      </p:grpSpPr>
-    </p:spTree>
-    <p:extLst>
-      <p:ext uri="{BB962C8B-B14F-4D97-AF65-F5344CB8AC3E}">
-        <p14:creationId xmlns:p14="http://schemas.microsoft.com/office/powerpoint/2010/main" val="361141122"/>
-      </p:ext>
-    </p:extLst>
-  </p:cSld>
-  <p:clrMapOvr>
-    <a:masterClrMapping/>
-  </p:clrMapOvr>
-  <p:timing>
-    <p:tnLst>
-      <p:par>
-        <p:cTn id="1" dur="indefinite" restart="never" nodeType="tmRoot"/>
-      </p:par>
-    </p:tnLst>
-  </p:timing>
-</p:sld>
-</file>
-
-<file path=ppt/slides/slide19.xml><?xml version="1.0" encoding="utf-8"?>
 <p:sld xmlns:a="http://schemas.openxmlformats.org/drawingml/2006/main" xmlns:r="http://schemas.openxmlformats.org/officeDocument/2006/relationships" xmlns:p="http://schemas.openxmlformats.org/presentationml/2006/main">
   <p:cSld>
     <p:spTree>
@@ -5411,8 +5239,8 @@
         </p:nvSpPr>
         <p:spPr>
           <a:xfrm>
-            <a:off x="1291996" y="3050184"/>
-            <a:ext cx="18549281" cy="808432"/>
+            <a:off x="1291996" y="3033772"/>
+            <a:ext cx="18549281" cy="841256"/>
           </a:xfrm>
           <a:prstGeom prst="rect">
             <a:avLst/>
@@ -5446,18 +5274,15 @@
               <a:buNone/>
             </a:pPr>
             <a:r>
-              <a:rPr lang="en-US" sz="4800" b="0" i="0" u="none" strike="noStrike" cap="none">
-                <a:solidFill>
-                  <a:srgbClr val="000000"/>
-                </a:solidFill>
+              <a:rPr lang="en-US" sz="4800" dirty="0">
                 <a:latin typeface="Helvetica Neue"/>
                 <a:ea typeface="Helvetica Neue"/>
                 <a:cs typeface="Helvetica Neue"/>
                 <a:sym typeface="Helvetica Neue"/>
               </a:rPr>
-              <a:t>Texto texto</a:t>
-            </a:r>
-            <a:endParaRPr sz="4800" b="0" i="0" u="none" strike="noStrike" cap="none">
+              <a:t>DEMONSTRAÇÃO DO PROJETO</a:t>
+            </a:r>
+            <a:endParaRPr sz="4800" b="0" i="0" u="none" strike="noStrike" cap="none" dirty="0">
               <a:solidFill>
                 <a:srgbClr val="000000"/>
               </a:solidFill>
@@ -5479,13 +5304,6 @@
   <p:clrMapOvr>
     <a:masterClrMapping/>
   </p:clrMapOvr>
-  <p:timing>
-    <p:tnLst>
-      <p:par>
-        <p:cTn id="1" dur="indefinite" restart="never" nodeType="tmRoot"/>
-      </p:par>
-    </p:tnLst>
-  </p:timing>
 </p:sld>
 </file>
 
@@ -5747,13 +5565,6 @@
   <p:clrMapOvr>
     <a:masterClrMapping/>
   </p:clrMapOvr>
-  <p:timing>
-    <p:tnLst>
-      <p:par>
-        <p:cTn id="1" dur="indefinite" restart="never" nodeType="tmRoot"/>
-      </p:par>
-    </p:tnLst>
-  </p:timing>
 </p:sld>
 </file>
 
@@ -5804,11 +5615,7 @@
             </a:pPr>
             <a:r>
               <a:rPr lang="pt-BR" sz="5400" b="1" dirty="0"/>
-              <a:t>PROBLEMA </a:t>
-            </a:r>
-            <a:r>
-              <a:rPr lang="pt-BR" sz="5400" b="1" dirty="0" smtClean="0"/>
-              <a:t>/ OBJETIVO</a:t>
+              <a:t>PROBLEMA / OBJETIVO</a:t>
             </a:r>
             <a:endParaRPr sz="5400" b="0" i="0" u="none" strike="noStrike" cap="none" dirty="0">
               <a:solidFill>
@@ -5854,11 +5661,7 @@
             </a:pPr>
             <a:r>
               <a:rPr lang="pt-BR" sz="4800" b="1" dirty="0"/>
-              <a:t>O envelhecimento populacional </a:t>
-            </a:r>
-            <a:r>
-              <a:rPr lang="pt-BR" sz="4800" b="1" dirty="0" smtClean="0"/>
-              <a:t>aumentou.</a:t>
+              <a:t>O envelhecimento populacional aumentou.</a:t>
             </a:r>
           </a:p>
           <a:p>
@@ -5874,30 +5677,17 @@
               <a:buChar char="•"/>
             </a:pPr>
             <a:r>
-              <a:rPr lang="pt-BR" sz="4800" b="1" dirty="0" smtClean="0"/>
-              <a:t>Famílias </a:t>
-            </a:r>
-            <a:r>
               <a:rPr lang="pt-BR" sz="4800" b="1" dirty="0"/>
-              <a:t>possuem dificuldade </a:t>
-            </a:r>
-            <a:endParaRPr lang="pt-BR" sz="4800" b="1" dirty="0" smtClean="0"/>
+              <a:t>Famílias possuem dificuldade </a:t>
+            </a:r>
           </a:p>
           <a:p>
             <a:pPr lvl="0">
               <a:buSzPts val="4800"/>
             </a:pPr>
             <a:r>
-              <a:rPr lang="pt-BR" sz="4800" b="1" dirty="0" smtClean="0"/>
-              <a:t>em </a:t>
-            </a:r>
-            <a:r>
               <a:rPr lang="pt-BR" sz="4800" b="1" dirty="0"/>
-              <a:t>encontrar </a:t>
-            </a:r>
-            <a:r>
-              <a:rPr lang="pt-BR" sz="4800" b="1" dirty="0" smtClean="0"/>
-              <a:t>cuidadores.</a:t>
+              <a:t>em encontrar cuidadores.</a:t>
             </a:r>
           </a:p>
           <a:p>
@@ -5913,30 +5703,17 @@
               <a:buChar char="•"/>
             </a:pPr>
             <a:r>
-              <a:rPr lang="pt-BR" sz="4800" b="1" dirty="0" smtClean="0"/>
-              <a:t>Elder </a:t>
-            </a:r>
-            <a:r>
-              <a:rPr lang="pt-BR" sz="4800" b="1" dirty="0" smtClean="0"/>
-              <a:t>Connect </a:t>
-            </a:r>
-            <a:r>
               <a:rPr lang="pt-BR" sz="4800" b="1" dirty="0"/>
-              <a:t>surge para conectar </a:t>
-            </a:r>
-            <a:endParaRPr lang="pt-BR" sz="4800" b="1" dirty="0" smtClean="0"/>
+              <a:t>Elder Connect surge para conectar </a:t>
+            </a:r>
           </a:p>
           <a:p>
             <a:pPr lvl="0">
               <a:buSzPts val="4800"/>
             </a:pPr>
             <a:r>
-              <a:rPr lang="pt-BR" sz="4800" b="1" dirty="0" smtClean="0"/>
-              <a:t>cuidadores </a:t>
-            </a:r>
-            <a:r>
               <a:rPr lang="pt-BR" sz="4800" b="1" dirty="0"/>
-              <a:t>e responsáveis</a:t>
+              <a:t>cuidadores e responsáveis</a:t>
             </a:r>
             <a:r>
               <a:rPr lang="pt-BR" sz="4800" dirty="0"/>
@@ -6028,13 +5805,6 @@
   <p:clrMapOvr>
     <a:masterClrMapping/>
   </p:clrMapOvr>
-  <p:timing>
-    <p:tnLst>
-      <p:par>
-        <p:cTn id="1" dur="indefinite" restart="never" nodeType="tmRoot"/>
-      </p:par>
-    </p:tnLst>
-  </p:timing>
 </p:sld>
 </file>
 
@@ -6085,11 +5855,7 @@
             </a:pPr>
             <a:r>
               <a:rPr lang="pt-BR" sz="5400" b="1" dirty="0"/>
-              <a:t>PROBLEMA </a:t>
-            </a:r>
-            <a:r>
-              <a:rPr lang="pt-BR" sz="5400" b="1" dirty="0" smtClean="0"/>
-              <a:t>E HIPÓTESE</a:t>
+              <a:t>PROBLEMA E HIPÓTESE</a:t>
             </a:r>
             <a:endParaRPr sz="5400" b="0" i="0" u="none" strike="noStrike" cap="none" dirty="0">
               <a:solidFill>
@@ -6132,7 +5898,7 @@
               <a:buSzPts val="4800"/>
             </a:pPr>
             <a:r>
-              <a:rPr lang="pt-BR" sz="4800" b="1" dirty="0" smtClean="0"/>
+              <a:rPr lang="pt-BR" sz="4800" b="1" dirty="0"/>
               <a:t>Problema</a:t>
             </a:r>
             <a:endParaRPr sz="4800" b="0" i="0" u="none" strike="noStrike" cap="none" dirty="0">
@@ -6176,7 +5942,7 @@
               <a:buSzPts val="4800"/>
             </a:pPr>
             <a:r>
-              <a:rPr lang="pt-BR" sz="4800" b="1" dirty="0" smtClean="0"/>
+              <a:rPr lang="pt-BR" sz="4800" b="1" dirty="0"/>
               <a:t>Hipótese</a:t>
             </a:r>
             <a:endParaRPr sz="4800" b="0" i="0" u="none" strike="noStrike" cap="none" dirty="0">
@@ -6222,11 +5988,7 @@
             </a:pPr>
             <a:r>
               <a:rPr lang="pt-BR" sz="3600" dirty="0"/>
-              <a:t>Dificuldade em encontrar </a:t>
-            </a:r>
-            <a:r>
-              <a:rPr lang="pt-BR" sz="3600" dirty="0" smtClean="0"/>
-              <a:t>cuidadores.</a:t>
+              <a:t>Dificuldade em encontrar cuidadores.</a:t>
             </a:r>
           </a:p>
           <a:p>
@@ -6235,16 +5997,8 @@
               <a:buChar char="•"/>
             </a:pPr>
             <a:r>
-              <a:rPr lang="pt-BR" sz="3600" dirty="0" smtClean="0"/>
-              <a:t>Falta </a:t>
-            </a:r>
-            <a:r>
               <a:rPr lang="pt-BR" sz="3600" dirty="0"/>
-              <a:t>de </a:t>
-            </a:r>
-            <a:r>
-              <a:rPr lang="pt-BR" sz="3600" dirty="0" smtClean="0"/>
-              <a:t>confiança.</a:t>
+              <a:t>Falta de confiança.</a:t>
             </a:r>
           </a:p>
         </p:txBody>
@@ -6276,11 +6030,7 @@
           <a:p>
             <a:r>
               <a:rPr lang="pt-BR" sz="3600" dirty="0"/>
-              <a:t>Um sistema web pode melhorar</a:t>
-            </a:r>
-            <a:r>
-              <a:rPr lang="pt-BR" sz="3600" dirty="0" smtClean="0"/>
-              <a:t>:</a:t>
+              <a:t>Um sistema web pode melhorar:</a:t>
             </a:r>
           </a:p>
           <a:p>
@@ -6415,7 +6165,6 @@
               <a:rPr lang="pt-BR" sz="3600" dirty="0"/>
               <a:t>Ausência de plataforma organizada.</a:t>
             </a:r>
-            <a:endParaRPr lang="pt-BR" sz="3600" dirty="0" smtClean="0"/>
           </a:p>
         </p:txBody>
       </p:sp>
@@ -6429,13 +6178,6 @@
   <p:clrMapOvr>
     <a:masterClrMapping/>
   </p:clrMapOvr>
-  <p:timing>
-    <p:tnLst>
-      <p:par>
-        <p:cTn id="1" dur="indefinite" restart="never" nodeType="tmRoot"/>
-      </p:par>
-    </p:tnLst>
-  </p:timing>
 </p:sld>
 </file>
 
@@ -6485,7 +6227,7 @@
               <a:buSzPts val="4800"/>
             </a:pPr>
             <a:r>
-              <a:rPr lang="pt-BR" sz="5400" b="1" dirty="0" smtClean="0"/>
+              <a:rPr lang="pt-BR" sz="5400" b="1" dirty="0"/>
               <a:t>OBJETIVOS DO PROJETO</a:t>
             </a:r>
             <a:endParaRPr lang="pt-BR" sz="5400" b="0" i="0" u="none" strike="noStrike" cap="none" dirty="0">
@@ -6527,11 +6269,7 @@
           <a:p>
             <a:r>
               <a:rPr lang="pt-BR" sz="4800" b="1" dirty="0"/>
-              <a:t>Desenvolver uma plataforma para facilitar</a:t>
-            </a:r>
-            <a:r>
-              <a:rPr lang="pt-BR" sz="4800" b="1" dirty="0" smtClean="0"/>
-              <a:t>:</a:t>
+              <a:t>Desenvolver uma plataforma para facilitar:</a:t>
             </a:r>
           </a:p>
           <a:p>
@@ -6631,13 +6369,6 @@
   <p:clrMapOvr>
     <a:masterClrMapping/>
   </p:clrMapOvr>
-  <p:timing>
-    <p:tnLst>
-      <p:par>
-        <p:cTn id="1" dur="indefinite" restart="never" nodeType="tmRoot"/>
-      </p:par>
-    </p:tnLst>
-  </p:timing>
 </p:sld>
 </file>
 
@@ -6832,13 +6563,6 @@
   <p:clrMapOvr>
     <a:masterClrMapping/>
   </p:clrMapOvr>
-  <p:timing>
-    <p:tnLst>
-      <p:par>
-        <p:cTn id="1" dur="indefinite" restart="never" nodeType="tmRoot"/>
-      </p:par>
-    </p:tnLst>
-  </p:timing>
 </p:sld>
 </file>
 
@@ -6888,7 +6612,7 @@
               <a:buSzPts val="4800"/>
             </a:pPr>
             <a:r>
-              <a:rPr lang="pt-BR" sz="4800" b="1" dirty="0" smtClean="0"/>
+              <a:rPr lang="pt-BR" sz="4800" b="1" dirty="0"/>
               <a:t>TECNOLOGIAS UTILIZADAS</a:t>
             </a:r>
             <a:endParaRPr lang="pt-BR" sz="4800" b="0" i="0" u="none" strike="noStrike" cap="none" dirty="0">
@@ -7264,13 +6988,6 @@
   <p:clrMapOvr>
     <a:masterClrMapping/>
   </p:clrMapOvr>
-  <p:timing>
-    <p:tnLst>
-      <p:par>
-        <p:cTn id="1" dur="indefinite" restart="never" nodeType="tmRoot"/>
-      </p:par>
-    </p:tnLst>
-  </p:timing>
 </p:sld>
 </file>
 
@@ -7320,7 +7037,7 @@
               <a:buSzPts val="4800"/>
             </a:pPr>
             <a:r>
-              <a:rPr lang="pt-BR" sz="4800" b="1" dirty="0" smtClean="0"/>
+              <a:rPr lang="pt-BR" sz="4800" b="1" dirty="0"/>
               <a:t>METODOLOGIA</a:t>
             </a:r>
             <a:endParaRPr lang="pt-BR" sz="4800" b="0" i="0" u="none" strike="noStrike" cap="none" dirty="0">
@@ -7395,13 +7112,6 @@
   <p:clrMapOvr>
     <a:masterClrMapping/>
   </p:clrMapOvr>
-  <p:timing>
-    <p:tnLst>
-      <p:par>
-        <p:cTn id="1" dur="indefinite" restart="never" nodeType="tmRoot"/>
-      </p:par>
-    </p:tnLst>
-  </p:timing>
 </p:sld>
 </file>
 
@@ -7451,7 +7161,7 @@
               <a:buSzPts val="4800"/>
             </a:pPr>
             <a:r>
-              <a:rPr lang="pt-BR" sz="5400" b="1" dirty="0" smtClean="0"/>
+              <a:rPr lang="pt-BR" sz="5400" b="1" dirty="0"/>
               <a:t>REQUISITOS FUNCIONAIS</a:t>
             </a:r>
             <a:endParaRPr lang="pt-BR" sz="5400" b="0" i="0" u="none" strike="noStrike" cap="none" dirty="0">
@@ -7493,11 +7203,7 @@
           <a:p>
             <a:r>
               <a:rPr lang="pt-BR" sz="4800" b="1" dirty="0"/>
-              <a:t>Módulo – Acesso e </a:t>
-            </a:r>
-            <a:r>
-              <a:rPr lang="pt-BR" sz="4800" b="1" dirty="0" smtClean="0"/>
-              <a:t>Conta</a:t>
+              <a:t>Módulo – Acesso e Conta</a:t>
             </a:r>
           </a:p>
           <a:p>
@@ -7616,13 +7322,6 @@
   <p:clrMapOvr>
     <a:masterClrMapping/>
   </p:clrMapOvr>
-  <p:timing>
-    <p:tnLst>
-      <p:par>
-        <p:cTn id="1" dur="indefinite" restart="never" nodeType="tmRoot"/>
-      </p:par>
-    </p:tnLst>
-  </p:timing>
 </p:sld>
 </file>
 

</xml_diff>